<commit_message>
Lesson sd-07-014, decks sd-07-012 and sd-07-014: separate the processor from the acquirer, restore the two inferences
Co-Authored-By: Claude Sonnet 5.5 <noreply@anthropic.com>
Claude-Session: https://claude.ai/code/session_01C1SaH6cnt22FTK5D8YYaoH
</commit_message>
<xml_diff>
--- a/system-design-101/vi/lessons/sd-07-012/slides/sd-07-012.pptx
+++ b/system-design-101/vi/lessons/sd-07-012/slides/sd-07-012.pptx
@@ -8378,7 +8378,7 @@
               <a:t> dòng</a:t>
             </a:r>
             <a:r>
-              <a:rPr lang="en-US" sz="2550" b="1" dirty="0" spc="0" kern="0">
+              <a:rPr lang="en-US" sz="2550" b="1" dirty="0" spc="-2" kern="0">
                 <a:solidFill>
                   <a:srgbClr val="14161C"/>
                 </a:solidFill>
@@ -8386,7 +8386,84 @@
                 <a:ea typeface="Be Vietnam Pro" pitchFamily="34" charset="-122"/>
                 <a:cs typeface="Be Vietnam Pro" pitchFamily="34" charset="-120"/>
               </a:rPr>
-              <a:t> cũ.</a:t>
+              <a:t> cũ;</a:t>
+            </a:r>
+            <a:r>
+              <a:rPr lang="en-US" sz="2550" b="1" dirty="0" spc="-7" kern="0">
+                <a:solidFill>
+                  <a:srgbClr val="14161C"/>
+                </a:solidFill>
+                <a:latin typeface="Be Vietnam Pro" pitchFamily="34" charset="0"/>
+                <a:ea typeface="Be Vietnam Pro" pitchFamily="34" charset="-122"/>
+                <a:cs typeface="Be Vietnam Pro" pitchFamily="34" charset="-120"/>
+              </a:rPr>
+              <a:t> tệp</a:t>
+            </a:r>
+            <a:r>
+              <a:rPr lang="en-US" sz="2550" b="1" dirty="0" spc="-17" kern="0">
+                <a:solidFill>
+                  <a:srgbClr val="14161C"/>
+                </a:solidFill>
+                <a:latin typeface="Be Vietnam Pro" pitchFamily="34" charset="0"/>
+                <a:ea typeface="Be Vietnam Pro" pitchFamily="34" charset="-122"/>
+                <a:cs typeface="Be Vietnam Pro" pitchFamily="34" charset="-120"/>
+              </a:rPr>
+              <a:t> quyết</a:t>
+            </a:r>
+            <a:r>
+              <a:rPr lang="en-US" sz="2550" b="1" dirty="0" spc="-3" kern="0">
+                <a:solidFill>
+                  <a:srgbClr val="14161C"/>
+                </a:solidFill>
+                <a:latin typeface="Be Vietnam Pro" pitchFamily="34" charset="0"/>
+                <a:ea typeface="Be Vietnam Pro" pitchFamily="34" charset="-122"/>
+                <a:cs typeface="Be Vietnam Pro" pitchFamily="34" charset="-120"/>
+              </a:rPr>
+              <a:t> toán hằng</a:t>
+            </a:r>
+            <a:r>
+              <a:rPr lang="en-US" sz="2550" b="1" dirty="0" spc="-1" kern="0">
+                <a:solidFill>
+                  <a:srgbClr val="14161C"/>
+                </a:solidFill>
+                <a:latin typeface="Be Vietnam Pro" pitchFamily="34" charset="0"/>
+                <a:ea typeface="Be Vietnam Pro" pitchFamily="34" charset="-122"/>
+                <a:cs typeface="Be Vietnam Pro" pitchFamily="34" charset="-120"/>
+              </a:rPr>
+              <a:t> đêm</a:t>
+            </a:r>
+            <a:r>
+              <a:rPr lang="en-US" sz="2550" b="1" dirty="0" spc="-3" kern="0">
+                <a:solidFill>
+                  <a:srgbClr val="14161C"/>
+                </a:solidFill>
+                <a:latin typeface="Be Vietnam Pro" pitchFamily="34" charset="0"/>
+                <a:ea typeface="Be Vietnam Pro" pitchFamily="34" charset="-122"/>
+                <a:cs typeface="Be Vietnam Pro" pitchFamily="34" charset="-120"/>
+              </a:rPr>
+              <a:t> dùng</a:t>
+            </a:r>
+            <a:r>
+              <a:rPr lang="en-US" sz="2550" b="1" dirty="0" spc="5" kern="0">
+                <a:solidFill>
+                  <a:srgbClr val="14161C"/>
+                </a:solidFill>
+                <a:latin typeface="Be Vietnam Pro" pitchFamily="34" charset="0"/>
+                <a:ea typeface="Be Vietnam Pro" pitchFamily="34" charset="-122"/>
+                <a:cs typeface="Be Vietnam Pro" pitchFamily="34" charset="-120"/>
+              </a:rPr>
+              <a:t> để đối</a:t>
+            </a:r>
+            <a:r>
+              <a:rPr lang="en-US" sz="2550" b="1" dirty="0" spc="-6" kern="0">
+                <a:solidFill>
+                  <a:srgbClr val="14161C"/>
+                </a:solidFill>
+                <a:latin typeface="Be Vietnam Pro" pitchFamily="34" charset="0"/>
+                <a:ea typeface="Be Vietnam Pro" pitchFamily="34" charset="-122"/>
+                <a:cs typeface="Be Vietnam Pro" pitchFamily="34" charset="-120"/>
+              </a:rPr>
+              <a:t> soát.</a:t>
             </a:r>
             <a:endParaRPr lang="en-US" sz="2550" dirty="0"/>
           </a:p>
@@ -8525,29 +8602,29 @@
               <a:t> điều</a:t>
             </a:r>
             <a:r>
-              <a:rPr lang="en-US" sz="2550" b="1" dirty="0" spc="-8" kern="0">
-                <a:solidFill>
-                  <a:srgbClr val="F3EEE3"/>
-                </a:solidFill>
-                <a:latin typeface="Be Vietnam Pro" pitchFamily="34" charset="0"/>
-                <a:ea typeface="Be Vietnam Pro" pitchFamily="34" charset="-122"/>
-                <a:cs typeface="Be Vietnam Pro" pitchFamily="34" charset="-120"/>
-              </a:rPr>
-              <a:t> trái</a:t>
-            </a:r>
-            <a:r>
-              <a:rPr lang="en-US" sz="2550" b="1" dirty="0" spc="-12" kern="0">
-                <a:solidFill>
-                  <a:srgbClr val="F3EEE3"/>
-                </a:solidFill>
-                <a:latin typeface="Be Vietnam Pro" pitchFamily="34" charset="0"/>
-                <a:ea typeface="Be Vietnam Pro" pitchFamily="34" charset="-122"/>
-                <a:cs typeface="Be Vietnam Pro" pitchFamily="34" charset="-120"/>
-              </a:rPr>
-              <a:t> này</a:t>
-            </a:r>
-            <a:r>
-              <a:rPr lang="en-US" sz="2550" b="1" dirty="0" spc="-6" kern="0">
+              <a:rPr lang="en-US" sz="2550" b="1" dirty="0" spc="1" kern="0">
+                <a:solidFill>
+                  <a:srgbClr val="F3EEE3"/>
+                </a:solidFill>
+                <a:latin typeface="Be Vietnam Pro" pitchFamily="34" charset="0"/>
+                <a:ea typeface="Be Vietnam Pro" pitchFamily="34" charset="-122"/>
+                <a:cs typeface="Be Vietnam Pro" pitchFamily="34" charset="-120"/>
+              </a:rPr>
+              <a:t> ở</a:t>
+            </a:r>
+            <a:r>
+              <a:rPr lang="en-US" sz="2550" b="1" dirty="0" spc="12" kern="0">
+                <a:solidFill>
+                  <a:srgbClr val="F3EEE3"/>
+                </a:solidFill>
+                <a:latin typeface="Be Vietnam Pro" pitchFamily="34" charset="0"/>
+                <a:ea typeface="Be Vietnam Pro" pitchFamily="34" charset="-122"/>
+                <a:cs typeface="Be Vietnam Pro" pitchFamily="34" charset="-120"/>
+              </a:rPr>
+              <a:t> giữa</a:t>
+            </a:r>
+            <a:r>
+              <a:rPr lang="en-US" sz="2550" b="1" dirty="0" spc="-5" kern="0">
                 <a:solidFill>
                   <a:srgbClr val="F3EEE3"/>
                 </a:solidFill>

</xml_diff>